<commit_message>
docs: format presentation with Lato and Lato Bold fonts and optimize slide layouts
</commit_message>
<xml_diff>
--- a/Mid Sem PPT.pptx
+++ b/Mid Sem PPT.pptx
@@ -3252,37 +3252,23 @@
           </a:bodyPr>
           <a:lstStyle/>
           <a:p>
-            <a:pPr>
-              <a:defRPr sz="2200" b="1">
+            <a:r>
+              <a:rPr b="1" sz="2400">
+                <a:solidFill>
+                  <a:srgbClr val="2563EB"/>
+                </a:solidFill>
+                <a:latin typeface="Lato"/>
+              </a:rPr>
+              <a:t>Project Title :- </a:t>
+            </a:r>
+            <a:r>
+              <a:rPr b="1" sz="2400">
                 <a:solidFill>
                   <a:srgbClr val="0F172A"/>
                 </a:solidFill>
-                <a:latin typeface="Open Sans"/>
-              </a:defRPr>
-            </a:pPr>
-            <a:r>
-              <a:rPr sz="3200" dirty="0">
-                <a:latin typeface="Lato Bold" panose="020B0604020202020204" charset="0"/>
-                <a:ea typeface="Lato Bold" panose="020B0604020202020204" charset="0"/>
-                <a:cs typeface="Lato Bold" panose="020B0604020202020204" charset="0"/>
-              </a:rPr>
-              <a:t>Project Title :- </a:t>
-            </a:r>
-            <a:r>
-              <a:rPr sz="3200" dirty="0" err="1">
-                <a:latin typeface="Lato Bold" panose="020B0604020202020204" charset="0"/>
-                <a:ea typeface="Lato Bold" panose="020B0604020202020204" charset="0"/>
-                <a:cs typeface="Lato Bold" panose="020B0604020202020204" charset="0"/>
-              </a:rPr>
-              <a:t>OScope</a:t>
-            </a:r>
-            <a:r>
-              <a:rPr sz="3200" dirty="0">
-                <a:latin typeface="Lato Bold" panose="020B0604020202020204" charset="0"/>
-                <a:ea typeface="Lato Bold" panose="020B0604020202020204" charset="0"/>
-                <a:cs typeface="Lato Bold" panose="020B0604020202020204" charset="0"/>
-              </a:rPr>
-              <a:t>: Operating Systems Simulation &amp; Experimentation Laboratory</a:t>
+                <a:latin typeface="Lato"/>
+              </a:rPr>
+              <a:t>OScope: Operating Systems Simulation &amp; Experimentation Laboratory</a:t>
             </a:r>
           </a:p>
         </p:txBody>
@@ -3308,29 +3294,24 @@
           </a:bodyPr>
           <a:lstStyle/>
           <a:p>
-            <a:pPr algn="ctr">
-              <a:lnSpc>
-                <a:spcPts val="4160"/>
-              </a:lnSpc>
-              <a:spcBef>
-                <a:spcPct val="0"/>
-              </a:spcBef>
-            </a:pPr>
-            <a:r>
-              <a:rPr sz="3200" dirty="0">
-                <a:latin typeface="Lato"/>
-              </a:rPr>
-              <a:t>DIV :- CSE(AI)-</a:t>
-            </a:r>
-            <a:r>
-              <a:rPr lang="en-US" sz="3200" dirty="0">
-                <a:latin typeface="Lato"/>
-              </a:rPr>
-              <a:t>E</a:t>
-            </a:r>
-            <a:endParaRPr sz="3200" dirty="0">
-              <a:latin typeface="Lato"/>
-            </a:endParaRPr>
+            <a:r>
+              <a:rPr b="1" sz="1800">
+                <a:solidFill>
+                  <a:srgbClr val="0F172A"/>
+                </a:solidFill>
+                <a:latin typeface="Lato"/>
+              </a:rPr>
+              <a:t>DIV :- </a:t>
+            </a:r>
+            <a:r>
+              <a:rPr b="0" sz="1800">
+                <a:solidFill>
+                  <a:srgbClr val="334155"/>
+                </a:solidFill>
+                <a:latin typeface="Lato"/>
+              </a:rPr>
+              <a:t>CSE(AI)-E</a:t>
+            </a:r>
           </a:p>
         </p:txBody>
       </p:sp>
@@ -3355,35 +3336,24 @@
           </a:bodyPr>
           <a:lstStyle/>
           <a:p>
-            <a:pPr algn="ctr">
-              <a:lnSpc>
-                <a:spcPts val="4160"/>
-              </a:lnSpc>
-              <a:spcBef>
-                <a:spcPct val="0"/>
-              </a:spcBef>
-            </a:pPr>
-            <a:r>
-              <a:rPr sz="3200" dirty="0">
-                <a:latin typeface="Lato"/>
-              </a:rPr>
-              <a:t>Day -</a:t>
-            </a:r>
-            <a:r>
-              <a:rPr lang="en-US" sz="3200" dirty="0">
-                <a:latin typeface="Lato"/>
-              </a:rPr>
-              <a:t> Friday</a:t>
-            </a:r>
-            <a:endParaRPr lang="en-US" sz="3200" dirty="0">
-              <a:solidFill>
-                <a:srgbClr val="000000"/>
-              </a:solidFill>
-              <a:latin typeface="Lato"/>
-              <a:ea typeface="Lato"/>
-              <a:cs typeface="Lato"/>
-              <a:sym typeface="Lato"/>
-            </a:endParaRPr>
+            <a:r>
+              <a:rPr b="1" sz="1800">
+                <a:solidFill>
+                  <a:srgbClr val="0F172A"/>
+                </a:solidFill>
+                <a:latin typeface="Lato"/>
+              </a:rPr>
+              <a:t>Day - </a:t>
+            </a:r>
+            <a:r>
+              <a:rPr b="0" sz="1800">
+                <a:solidFill>
+                  <a:srgbClr val="334155"/>
+                </a:solidFill>
+                <a:latin typeface="Lato"/>
+              </a:rPr>
+              <a:t>Friday</a:t>
+            </a:r>
           </a:p>
         </p:txBody>
       </p:sp>
@@ -3408,18 +3378,23 @@
           </a:bodyPr>
           <a:lstStyle/>
           <a:p>
-            <a:pPr>
-              <a:defRPr sz="1800">
-                <a:latin typeface="Open Sans"/>
-              </a:defRPr>
-            </a:pPr>
-            <a:r>
-              <a:rPr sz="3200" dirty="0">
-                <a:latin typeface="Lato" panose="020F0502020204030203" pitchFamily="34" charset="0"/>
-                <a:ea typeface="Lato" panose="020F0502020204030203" pitchFamily="34" charset="0"/>
-                <a:cs typeface="Lato" panose="020F0502020204030203" pitchFamily="34" charset="0"/>
-              </a:rPr>
-              <a:t>Date : 30/10/2026</a:t>
+            <a:r>
+              <a:rPr b="1" sz="1800">
+                <a:solidFill>
+                  <a:srgbClr val="0F172A"/>
+                </a:solidFill>
+                <a:latin typeface="Lato"/>
+              </a:rPr>
+              <a:t>Date : </a:t>
+            </a:r>
+            <a:r>
+              <a:rPr b="0" sz="1800">
+                <a:solidFill>
+                  <a:srgbClr val="334155"/>
+                </a:solidFill>
+                <a:latin typeface="Lato"/>
+              </a:rPr>
+              <a:t>30/10/2026</a:t>
             </a:r>
           </a:p>
         </p:txBody>
@@ -3445,116 +3420,155 @@
           </a:bodyPr>
           <a:lstStyle/>
           <a:p>
-            <a:pPr algn="l">
-              <a:lnSpc>
-                <a:spcPts val="4160"/>
-              </a:lnSpc>
-              <a:spcBef>
-                <a:spcPct val="0"/>
-              </a:spcBef>
+            <a:pPr>
               <a:spcAft>
-                <a:spcPts val="0"/>
+                <a:spcPts val="800"/>
               </a:spcAft>
             </a:pPr>
             <a:r>
-              <a:rPr sz="3200" b="1" dirty="0">
-                <a:latin typeface="Lato" panose="020F0502020204030203" pitchFamily="34" charset="0"/>
-                <a:ea typeface="Lato" panose="020F0502020204030203" pitchFamily="34" charset="0"/>
-                <a:cs typeface="Lato" panose="020F0502020204030203" pitchFamily="34" charset="0"/>
+              <a:rPr b="1" sz="2000">
+                <a:solidFill>
+                  <a:srgbClr val="0F172A"/>
+                </a:solidFill>
+                <a:latin typeface="Lato"/>
               </a:rPr>
               <a:t>Presented by :-</a:t>
             </a:r>
           </a:p>
           <a:p>
-            <a:pPr algn="l">
+            <a:pPr>
               <a:spcAft>
-                <a:spcPts val="0"/>
+                <a:spcPts val="400"/>
               </a:spcAft>
             </a:pPr>
             <a:r>
-              <a:rPr sz="3200" dirty="0">
-                <a:latin typeface="Lato" panose="020F0502020204030203" pitchFamily="34" charset="0"/>
-                <a:ea typeface="Lato" panose="020F0502020204030203" pitchFamily="34" charset="0"/>
-                <a:cs typeface="Lato" panose="020F0502020204030203" pitchFamily="34" charset="0"/>
-              </a:rPr>
-              <a:t>Aditya Rana  </a:t>
-            </a:r>
-            <a:r>
-              <a:rPr lang="en-US" sz="3200" dirty="0">
-                <a:latin typeface="Lato" panose="020F0502020204030203" pitchFamily="34" charset="0"/>
-                <a:ea typeface="Lato" panose="020F0502020204030203" pitchFamily="34" charset="0"/>
-                <a:cs typeface="Lato" panose="020F0502020204030203" pitchFamily="34" charset="0"/>
-              </a:rPr>
-              <a:t>  </a:t>
-            </a:r>
-            <a:r>
-              <a:rPr sz="3200" dirty="0">
-                <a:latin typeface="Lato" panose="020F0502020204030203" pitchFamily="34" charset="0"/>
-                <a:ea typeface="Lato" panose="020F0502020204030203" pitchFamily="34" charset="0"/>
-                <a:cs typeface="Lato" panose="020F0502020204030203" pitchFamily="34" charset="0"/>
-              </a:rPr>
-              <a:t>–  PRN: 12413107</a:t>
-            </a:r>
-          </a:p>
-          <a:p>
-            <a:pPr algn="l">
+              <a:rPr b="1" sz="1700">
+                <a:solidFill>
+                  <a:srgbClr val="0F172A"/>
+                </a:solidFill>
+                <a:latin typeface="Lato"/>
+              </a:rPr>
+              <a:t>Aditya Rana </a:t>
+            </a:r>
+            <a:r>
+              <a:rPr b="0" sz="1700">
+                <a:solidFill>
+                  <a:srgbClr val="64748B"/>
+                </a:solidFill>
+                <a:latin typeface="Lato"/>
+              </a:rPr>
+              <a:t>  —  PRN: </a:t>
+            </a:r>
+            <a:r>
+              <a:rPr b="1" sz="1700">
+                <a:solidFill>
+                  <a:srgbClr val="2563EB"/>
+                </a:solidFill>
+                <a:latin typeface="Lato"/>
+              </a:rPr>
+              <a:t>12413107</a:t>
+            </a:r>
+          </a:p>
+          <a:p>
+            <a:pPr>
               <a:spcAft>
-                <a:spcPts val="0"/>
+                <a:spcPts val="400"/>
               </a:spcAft>
             </a:pPr>
             <a:r>
-              <a:rPr sz="3200" dirty="0">
-                <a:latin typeface="Lato" panose="020F0502020204030203" pitchFamily="34" charset="0"/>
-                <a:ea typeface="Lato" panose="020F0502020204030203" pitchFamily="34" charset="0"/>
-                <a:cs typeface="Lato" panose="020F0502020204030203" pitchFamily="34" charset="0"/>
-              </a:rPr>
-              <a:t>Nitish Sahu  </a:t>
-            </a:r>
-            <a:r>
-              <a:rPr lang="en-US" sz="3200" dirty="0">
-                <a:latin typeface="Lato" panose="020F0502020204030203" pitchFamily="34" charset="0"/>
-                <a:ea typeface="Lato" panose="020F0502020204030203" pitchFamily="34" charset="0"/>
-                <a:cs typeface="Lato" panose="020F0502020204030203" pitchFamily="34" charset="0"/>
-              </a:rPr>
-              <a:t>   </a:t>
-            </a:r>
-            <a:r>
-              <a:rPr sz="3200" dirty="0">
-                <a:latin typeface="Lato" panose="020F0502020204030203" pitchFamily="34" charset="0"/>
-                <a:ea typeface="Lato" panose="020F0502020204030203" pitchFamily="34" charset="0"/>
-                <a:cs typeface="Lato" panose="020F0502020204030203" pitchFamily="34" charset="0"/>
-              </a:rPr>
-              <a:t>–  PRN: 12412096</a:t>
-            </a:r>
-          </a:p>
-          <a:p>
-            <a:pPr algn="l">
+              <a:rPr b="1" sz="1700">
+                <a:solidFill>
+                  <a:srgbClr val="0F172A"/>
+                </a:solidFill>
+                <a:latin typeface="Lato"/>
+              </a:rPr>
+              <a:t>Nitish Sahu </a:t>
+            </a:r>
+            <a:r>
+              <a:rPr b="0" sz="1700">
+                <a:solidFill>
+                  <a:srgbClr val="64748B"/>
+                </a:solidFill>
+                <a:latin typeface="Lato"/>
+              </a:rPr>
+              <a:t>  —  PRN: </a:t>
+            </a:r>
+            <a:r>
+              <a:rPr b="1" sz="1700">
+                <a:solidFill>
+                  <a:srgbClr val="2563EB"/>
+                </a:solidFill>
+                <a:latin typeface="Lato"/>
+              </a:rPr>
+              <a:t>12412096</a:t>
+            </a:r>
+          </a:p>
+          <a:p>
+            <a:pPr>
               <a:spcAft>
-                <a:spcPts val="0"/>
+                <a:spcPts val="400"/>
               </a:spcAft>
             </a:pPr>
             <a:r>
-              <a:rPr sz="3200" dirty="0">
-                <a:latin typeface="Lato" panose="020F0502020204030203" pitchFamily="34" charset="0"/>
-                <a:ea typeface="Lato" panose="020F0502020204030203" pitchFamily="34" charset="0"/>
-                <a:cs typeface="Lato" panose="020F0502020204030203" pitchFamily="34" charset="0"/>
-              </a:rPr>
-              <a:t>Palash Sahuji  –  PRN: 12414915</a:t>
-            </a:r>
-          </a:p>
-          <a:p>
-            <a:pPr algn="l">
+              <a:rPr b="1" sz="1700">
+                <a:solidFill>
+                  <a:srgbClr val="0F172A"/>
+                </a:solidFill>
+                <a:latin typeface="Lato"/>
+              </a:rPr>
+              <a:t>Palash Sahuji </a:t>
+            </a:r>
+            <a:r>
+              <a:rPr b="0" sz="1700">
+                <a:solidFill>
+                  <a:srgbClr val="64748B"/>
+                </a:solidFill>
+                <a:latin typeface="Lato"/>
+              </a:rPr>
+              <a:t>  —  PRN: </a:t>
+            </a:r>
+            <a:r>
+              <a:rPr b="1" sz="1700">
+                <a:solidFill>
+                  <a:srgbClr val="2563EB"/>
+                </a:solidFill>
+                <a:latin typeface="Lato"/>
+              </a:rPr>
+              <a:t>12414915</a:t>
+            </a:r>
+          </a:p>
+          <a:p>
+            <a:pPr>
               <a:spcAft>
-                <a:spcPts val="0"/>
+                <a:spcPts val="400"/>
               </a:spcAft>
             </a:pPr>
             <a:r>
-              <a:rPr sz="3200" dirty="0">
-                <a:latin typeface="Lato" panose="020F0502020204030203" pitchFamily="34" charset="0"/>
-                <a:ea typeface="Lato" panose="020F0502020204030203" pitchFamily="34" charset="0"/>
-                <a:cs typeface="Lato" panose="020F0502020204030203" pitchFamily="34" charset="0"/>
-              </a:rPr>
-              <a:t>Manthan Sali  –  PRN: 12411978</a:t>
+              <a:rPr b="1" sz="1700">
+                <a:solidFill>
+                  <a:srgbClr val="0F172A"/>
+                </a:solidFill>
+                <a:latin typeface="Lato"/>
+              </a:rPr>
+              <a:t>Manthan Sali </a:t>
+            </a:r>
+            <a:r>
+              <a:rPr b="0" sz="1700">
+                <a:solidFill>
+                  <a:srgbClr val="64748B"/>
+                </a:solidFill>
+                <a:latin typeface="Lato"/>
+              </a:rPr>
+              <a:t>  —  PRN: </a:t>
+            </a:r>
+            <a:r>
+              <a:rPr b="1" sz="1700">
+                <a:solidFill>
+                  <a:srgbClr val="2563EB"/>
+                </a:solidFill>
+                <a:latin typeface="Lato"/>
+              </a:rPr>
+              <a:t>12411978</a:t>
             </a:r>
           </a:p>
         </p:txBody>
@@ -3580,43 +3594,24 @@
           </a:bodyPr>
           <a:lstStyle/>
           <a:p>
-            <a:pPr algn="ctr">
-              <a:lnSpc>
-                <a:spcPts val="4160"/>
-              </a:lnSpc>
-              <a:spcBef>
-                <a:spcPct val="0"/>
-              </a:spcBef>
-            </a:pPr>
-            <a:r>
-              <a:rPr sz="3200" b="1" dirty="0">
-                <a:latin typeface="Lato" panose="020F0502020204030203" pitchFamily="34" charset="0"/>
-                <a:ea typeface="Lato" panose="020F0502020204030203" pitchFamily="34" charset="0"/>
-                <a:cs typeface="Lato" panose="020F0502020204030203" pitchFamily="34" charset="0"/>
-              </a:rPr>
-              <a:t>Project Guide :- Prof. </a:t>
-            </a:r>
-            <a:r>
-              <a:rPr lang="en-IN" sz="3200" b="1" dirty="0">
-                <a:latin typeface="Lato" panose="020F0502020204030203" pitchFamily="34" charset="0"/>
-                <a:ea typeface="Lato" panose="020F0502020204030203" pitchFamily="34" charset="0"/>
-                <a:cs typeface="Lato" panose="020F0502020204030203" pitchFamily="34" charset="0"/>
-              </a:rPr>
-              <a:t>Priyanka </a:t>
-            </a:r>
-            <a:r>
-              <a:rPr lang="en-IN" sz="3200" b="1" dirty="0" err="1">
-                <a:latin typeface="Lato" panose="020F0502020204030203" pitchFamily="34" charset="0"/>
-                <a:ea typeface="Lato" panose="020F0502020204030203" pitchFamily="34" charset="0"/>
-                <a:cs typeface="Lato" panose="020F0502020204030203" pitchFamily="34" charset="0"/>
-              </a:rPr>
-              <a:t>Khalate</a:t>
-            </a:r>
-            <a:endParaRPr sz="3200" b="1" dirty="0">
-              <a:latin typeface="Lato" panose="020F0502020204030203" pitchFamily="34" charset="0"/>
-              <a:ea typeface="Lato" panose="020F0502020204030203" pitchFamily="34" charset="0"/>
-              <a:cs typeface="Lato" panose="020F0502020204030203" pitchFamily="34" charset="0"/>
-            </a:endParaRPr>
+            <a:r>
+              <a:rPr b="1" sz="2000">
+                <a:solidFill>
+                  <a:srgbClr val="0F172A"/>
+                </a:solidFill>
+                <a:latin typeface="Lato"/>
+              </a:rPr>
+              <a:t>Project Guide :- </a:t>
+            </a:r>
+            <a:r>
+              <a:rPr b="1" sz="2000">
+                <a:solidFill>
+                  <a:srgbClr val="2563EB"/>
+                </a:solidFill>
+                <a:latin typeface="Lato"/>
+              </a:rPr>
+              <a:t>Prof. Priyanka Khalate</a:t>
+            </a:r>
           </a:p>
         </p:txBody>
       </p:sp>
@@ -3641,59 +3636,16 @@
           </a:bodyPr>
           <a:lstStyle/>
           <a:p>
-            <a:pPr algn="ctr">
-              <a:lnSpc>
-                <a:spcPts val="4376"/>
-              </a:lnSpc>
-              <a:spcBef>
-                <a:spcPct val="0"/>
-              </a:spcBef>
-            </a:pPr>
-            <a:r>
-              <a:rPr lang="en-US" sz="3366" b="1" dirty="0">
-                <a:solidFill>
-                  <a:srgbClr val="000000"/>
-                </a:solidFill>
-                <a:latin typeface="Times New Roman" panose="02020603050405020304" pitchFamily="18" charset="0"/>
-                <a:ea typeface="Lato Bold"/>
-                <a:cs typeface="Times New Roman" panose="02020603050405020304" pitchFamily="18" charset="0"/>
-                <a:sym typeface="Lato Bold"/>
-              </a:rPr>
-              <a:t>DEPARTMENT OF COMPUTER SCIENCE ENGINEERING </a:t>
-            </a:r>
-          </a:p>
-          <a:p>
-            <a:pPr algn="ctr">
-              <a:lnSpc>
-                <a:spcPts val="4376"/>
-              </a:lnSpc>
-              <a:spcBef>
-                <a:spcPct val="0"/>
-              </a:spcBef>
-            </a:pPr>
-            <a:r>
-              <a:rPr lang="en-US" sz="3366" b="1" dirty="0">
-                <a:solidFill>
-                  <a:srgbClr val="000000"/>
-                </a:solidFill>
-                <a:latin typeface="Times New Roman" panose="02020603050405020304" pitchFamily="18" charset="0"/>
-                <a:ea typeface="Lato Bold"/>
-                <a:cs typeface="Times New Roman" panose="02020603050405020304" pitchFamily="18" charset="0"/>
-                <a:sym typeface="Lato Bold"/>
-              </a:rPr>
-              <a:t>(ARTIFICIAL INTELLIGENCE </a:t>
-            </a:r>
-            <a:r>
-              <a:rPr lang="en-US" sz="3366" b="1" dirty="0">
-                <a:solidFill>
-                  <a:srgbClr val="000000"/>
-                </a:solidFill>
-                <a:latin typeface="Lato Bold"/>
-                <a:ea typeface="Lato Bold"/>
-                <a:cs typeface="Lato Bold"/>
-                <a:sym typeface="Lato Bold"/>
-              </a:rPr>
-              <a:t>)</a:t>
+            <a:pPr algn="ctr"/>
+            <a:r>
+              <a:rPr b="1" sz="2000">
+                <a:solidFill>
+                  <a:srgbClr val="0F172A"/>
+                </a:solidFill>
+                <a:latin typeface="Lato"/>
+              </a:rPr>
+              <a:t>DEPARTMENT OF COMPUTER SCIENCE ENGINEERING
+(ARTIFICIAL INTELLIGENCE)</a:t>
             </a:r>
           </a:p>
         </p:txBody>
@@ -3719,23 +3671,13 @@
           </a:bodyPr>
           <a:lstStyle/>
           <a:p>
-            <a:pPr algn="ctr">
-              <a:lnSpc>
-                <a:spcPts val="4550"/>
-              </a:lnSpc>
-              <a:spcBef>
-                <a:spcPct val="0"/>
-              </a:spcBef>
-            </a:pPr>
-            <a:r>
-              <a:rPr lang="en-US" sz="3500" b="1" dirty="0">
-                <a:solidFill>
-                  <a:srgbClr val="000000"/>
-                </a:solidFill>
-                <a:latin typeface="Times New Roman" panose="02020603050405020304" pitchFamily="18" charset="0"/>
-                <a:ea typeface="Lato Bold"/>
-                <a:cs typeface="Times New Roman" panose="02020603050405020304" pitchFamily="18" charset="0"/>
-                <a:sym typeface="Lato Bold"/>
+            <a:pPr algn="ctr"/>
+            <a:r>
+              <a:rPr b="1" sz="2200">
+                <a:solidFill>
+                  <a:srgbClr val="2563EB"/>
+                </a:solidFill>
+                <a:latin typeface="Lato"/>
               </a:rPr>
               <a:t>VISHWAKARMA INSTITUTE OF TECHNOLOGY, PUNE</a:t>
             </a:r>
@@ -4257,36 +4199,25 @@
         </p:nvSpPr>
         <p:spPr>
           <a:xfrm>
-            <a:off x="1723107" y="900442"/>
-            <a:ext cx="9354483" cy="1194686"/>
+            <a:off x="1097280" y="777240"/>
+            <a:ext cx="12801600" cy="1097280"/>
           </a:xfrm>
           <a:prstGeom prst="rect">
             <a:avLst/>
           </a:prstGeom>
         </p:spPr>
         <p:txBody>
-          <a:bodyPr lIns="0" tIns="0" rIns="0" bIns="0" rtlCol="0" anchor="t">
+          <a:bodyPr lIns="0" tIns="0" rIns="0" bIns="0" rtlCol="0" anchor="t" wrap="square">
             <a:spAutoFit/>
           </a:bodyPr>
           <a:lstStyle/>
           <a:p>
-            <a:pPr>
-              <a:lnSpc>
-                <a:spcPts val="10248"/>
-              </a:lnSpc>
-              <a:spcBef>
-                <a:spcPct val="0"/>
-              </a:spcBef>
-            </a:pPr>
-            <a:r>
-              <a:rPr lang="en-US" sz="6000" dirty="0">
-                <a:solidFill>
-                  <a:srgbClr val="051D40"/>
-                </a:solidFill>
-                <a:latin typeface="Open Sans Extra Bold"/>
-                <a:ea typeface="Open Sans Extra Bold"/>
-                <a:cs typeface="Open Sans Extra Bold"/>
-                <a:sym typeface="Open Sans Extra Bold"/>
+            <a:r>
+              <a:rPr b="1" sz="4400">
+                <a:solidFill>
+                  <a:srgbClr val="0F172A"/>
+                </a:solidFill>
+                <a:latin typeface="Lato"/>
               </a:rPr>
               <a:t>Overview</a:t>
             </a:r>
@@ -4356,8 +4287,8 @@
         </p:nvSpPr>
         <p:spPr>
           <a:xfrm>
-            <a:off x="2926080" y="2377440"/>
-            <a:ext cx="12435840" cy="6786666"/>
+            <a:off x="1645920" y="2194560"/>
+            <a:ext cx="14996159" cy="7132320"/>
           </a:xfrm>
           <a:prstGeom prst="rect">
             <a:avLst/>
@@ -4371,20 +4302,18 @@
           <a:p>
             <a:pPr>
               <a:lnSpc>
-                <a:spcPct val="120000"/>
+                <a:spcPct val="122000"/>
               </a:lnSpc>
               <a:spcAft>
-                <a:spcPts val="1400"/>
+                <a:spcPts val="1800"/>
               </a:spcAft>
             </a:pPr>
             <a:r>
-              <a:rPr sz="3200" b="0" dirty="0">
-                <a:solidFill>
-                  <a:srgbClr val="0F172A"/>
-                </a:solidFill>
-                <a:latin typeface="Lato" panose="020F0502020204030203" pitchFamily="34" charset="0"/>
-                <a:ea typeface="Lato" panose="020F0502020204030203" pitchFamily="34" charset="0"/>
-                <a:cs typeface="Lato" panose="020F0502020204030203" pitchFamily="34" charset="0"/>
+              <a:rPr b="0" sz="2200">
+                <a:solidFill>
+                  <a:srgbClr val="334155"/>
+                </a:solidFill>
+                <a:latin typeface="Lato"/>
               </a:rPr>
               <a:t>1. Introduction &amp; Project Scope</a:t>
             </a:r>
@@ -4392,20 +4321,18 @@
           <a:p>
             <a:pPr>
               <a:lnSpc>
-                <a:spcPct val="120000"/>
+                <a:spcPct val="122000"/>
               </a:lnSpc>
               <a:spcAft>
-                <a:spcPts val="1400"/>
+                <a:spcPts val="1800"/>
               </a:spcAft>
             </a:pPr>
             <a:r>
-              <a:rPr sz="3200" b="0" dirty="0">
-                <a:solidFill>
-                  <a:srgbClr val="0F172A"/>
-                </a:solidFill>
-                <a:latin typeface="Lato" panose="020F0502020204030203" pitchFamily="34" charset="0"/>
-                <a:ea typeface="Lato" panose="020F0502020204030203" pitchFamily="34" charset="0"/>
-                <a:cs typeface="Lato" panose="020F0502020204030203" pitchFamily="34" charset="0"/>
+              <a:rPr b="0" sz="2200">
+                <a:solidFill>
+                  <a:srgbClr val="334155"/>
+                </a:solidFill>
+                <a:latin typeface="Lato"/>
               </a:rPr>
               <a:t>2. Motivation &amp; Problem Statement</a:t>
             </a:r>
@@ -4413,148 +4340,96 @@
           <a:p>
             <a:pPr>
               <a:lnSpc>
-                <a:spcPct val="120000"/>
+                <a:spcPct val="122000"/>
               </a:lnSpc>
               <a:spcAft>
-                <a:spcPts val="1400"/>
+                <a:spcPts val="1800"/>
               </a:spcAft>
             </a:pPr>
             <a:r>
-              <a:rPr sz="3200" b="0" dirty="0">
-                <a:solidFill>
-                  <a:srgbClr val="0F172A"/>
-                </a:solidFill>
-                <a:latin typeface="Lato" panose="020F0502020204030203" pitchFamily="34" charset="0"/>
-                <a:ea typeface="Lato" panose="020F0502020204030203" pitchFamily="34" charset="0"/>
-                <a:cs typeface="Lato" panose="020F0502020204030203" pitchFamily="34" charset="0"/>
-              </a:rPr>
-              <a:t>3. Literature Survey (Pedagogical Systems &amp; Simulators)</a:t>
+              <a:rPr b="0" sz="2200">
+                <a:solidFill>
+                  <a:srgbClr val="334155"/>
+                </a:solidFill>
+                <a:latin typeface="Lato"/>
+              </a:rPr>
+              <a:t>3. Project Objectives &amp; Deliverables</a:t>
             </a:r>
           </a:p>
           <a:p>
             <a:pPr>
               <a:lnSpc>
-                <a:spcPct val="120000"/>
+                <a:spcPct val="122000"/>
               </a:lnSpc>
               <a:spcAft>
-                <a:spcPts val="1400"/>
+                <a:spcPts val="1800"/>
               </a:spcAft>
             </a:pPr>
             <a:r>
-              <a:rPr sz="3200" b="0" dirty="0">
-                <a:solidFill>
-                  <a:srgbClr val="0F172A"/>
-                </a:solidFill>
-                <a:latin typeface="Lato" panose="020F0502020204030203" pitchFamily="34" charset="0"/>
-                <a:ea typeface="Lato" panose="020F0502020204030203" pitchFamily="34" charset="0"/>
-                <a:cs typeface="Lato" panose="020F0502020204030203" pitchFamily="34" charset="0"/>
-              </a:rPr>
-              <a:t>4. Research Gap &amp; Comparative Analysis</a:t>
+              <a:rPr b="0" sz="2200">
+                <a:solidFill>
+                  <a:srgbClr val="334155"/>
+                </a:solidFill>
+                <a:latin typeface="Lato"/>
+              </a:rPr>
+              <a:t>4. Design &amp; 4-Tier System Architecture</a:t>
             </a:r>
           </a:p>
           <a:p>
             <a:pPr>
               <a:lnSpc>
-                <a:spcPct val="120000"/>
+                <a:spcPct val="122000"/>
               </a:lnSpc>
               <a:spcAft>
-                <a:spcPts val="1400"/>
+                <a:spcPts val="1800"/>
               </a:spcAft>
             </a:pPr>
             <a:r>
-              <a:rPr sz="3200" b="0" dirty="0">
-                <a:solidFill>
-                  <a:srgbClr val="0F172A"/>
-                </a:solidFill>
-                <a:latin typeface="Lato" panose="020F0502020204030203" pitchFamily="34" charset="0"/>
-                <a:ea typeface="Lato" panose="020F0502020204030203" pitchFamily="34" charset="0"/>
-                <a:cs typeface="Lato" panose="020F0502020204030203" pitchFamily="34" charset="0"/>
-              </a:rPr>
-              <a:t>5. Project Objectives &amp; Deliverables</a:t>
+              <a:rPr b="0" sz="2200">
+                <a:solidFill>
+                  <a:srgbClr val="334155"/>
+                </a:solidFill>
+                <a:latin typeface="Lato"/>
+              </a:rPr>
+              <a:t>5. Technical Stack &amp; Implementation Details</a:t>
             </a:r>
           </a:p>
           <a:p>
             <a:pPr>
               <a:lnSpc>
-                <a:spcPct val="120000"/>
+                <a:spcPct val="122000"/>
               </a:lnSpc>
               <a:spcAft>
-                <a:spcPts val="1400"/>
+                <a:spcPts val="1800"/>
               </a:spcAft>
             </a:pPr>
             <a:r>
-              <a:rPr sz="3200" b="0" dirty="0">
-                <a:solidFill>
-                  <a:srgbClr val="0F172A"/>
-                </a:solidFill>
-                <a:latin typeface="Lato" panose="020F0502020204030203" pitchFamily="34" charset="0"/>
-                <a:ea typeface="Lato" panose="020F0502020204030203" pitchFamily="34" charset="0"/>
-                <a:cs typeface="Lato" panose="020F0502020204030203" pitchFamily="34" charset="0"/>
-              </a:rPr>
-              <a:t>6. Design &amp; 4-Tier System Architecture</a:t>
+              <a:rPr b="0" sz="2200">
+                <a:solidFill>
+                  <a:srgbClr val="334155"/>
+                </a:solidFill>
+                <a:latin typeface="Lato"/>
+              </a:rPr>
+              <a:t>6. Academic References &amp; Citations</a:t>
             </a:r>
           </a:p>
           <a:p>
             <a:pPr>
               <a:lnSpc>
-                <a:spcPct val="120000"/>
+                <a:spcPct val="122000"/>
               </a:lnSpc>
               <a:spcAft>
-                <a:spcPts val="1400"/>
+                <a:spcPts val="1800"/>
               </a:spcAft>
             </a:pPr>
             <a:r>
-              <a:rPr sz="3200" b="0" dirty="0">
-                <a:solidFill>
-                  <a:srgbClr val="0F172A"/>
-                </a:solidFill>
-                <a:latin typeface="Lato" panose="020F0502020204030203" pitchFamily="34" charset="0"/>
-                <a:ea typeface="Lato" panose="020F0502020204030203" pitchFamily="34" charset="0"/>
-                <a:cs typeface="Lato" panose="020F0502020204030203" pitchFamily="34" charset="0"/>
-              </a:rPr>
-              <a:t>7. Technical Stack &amp; Implementation Details</a:t>
-            </a:r>
-          </a:p>
-          <a:p>
-            <a:pPr>
-              <a:lnSpc>
-                <a:spcPct val="120000"/>
-              </a:lnSpc>
-              <a:spcAft>
-                <a:spcPts val="1400"/>
-              </a:spcAft>
-            </a:pPr>
-            <a:r>
-              <a:rPr sz="3200" b="0" dirty="0">
-                <a:solidFill>
-                  <a:srgbClr val="0F172A"/>
-                </a:solidFill>
-                <a:latin typeface="Lato" panose="020F0502020204030203" pitchFamily="34" charset="0"/>
-                <a:ea typeface="Lato" panose="020F0502020204030203" pitchFamily="34" charset="0"/>
-                <a:cs typeface="Lato" panose="020F0502020204030203" pitchFamily="34" charset="0"/>
-              </a:rPr>
-              <a:t>8. Academic References &amp; Citations</a:t>
-            </a:r>
-          </a:p>
-          <a:p>
-            <a:pPr>
-              <a:lnSpc>
-                <a:spcPct val="120000"/>
-              </a:lnSpc>
-              <a:spcAft>
-                <a:spcPts val="1400"/>
-              </a:spcAft>
-            </a:pPr>
-            <a:r>
-              <a:rPr sz="3200" b="0" dirty="0">
-                <a:solidFill>
-                  <a:srgbClr val="0F172A"/>
-                </a:solidFill>
-                <a:latin typeface="Lato" panose="020F0502020204030203" pitchFamily="34" charset="0"/>
-                <a:ea typeface="Lato" panose="020F0502020204030203" pitchFamily="34" charset="0"/>
-                <a:cs typeface="Lato" panose="020F0502020204030203" pitchFamily="34" charset="0"/>
-              </a:rPr>
-              <a:t>9. Conclusion &amp; Project Summary</a:t>
+              <a:rPr b="0" sz="2200">
+                <a:solidFill>
+                  <a:srgbClr val="334155"/>
+                </a:solidFill>
+                <a:latin typeface="Lato"/>
+              </a:rPr>
+              <a:t>7. Conclusion &amp; Project Summary</a:t>
             </a:r>
           </a:p>
         </p:txBody>
@@ -4978,30 +4853,25 @@
         </p:nvSpPr>
         <p:spPr>
           <a:xfrm>
-            <a:off x="1723107" y="674021"/>
-            <a:ext cx="9354483" cy="1194686"/>
+            <a:off x="1097280" y="777240"/>
+            <a:ext cx="12801600" cy="1097280"/>
           </a:xfrm>
           <a:prstGeom prst="rect">
             <a:avLst/>
           </a:prstGeom>
         </p:spPr>
         <p:txBody>
-          <a:bodyPr lIns="0" tIns="0" rIns="0" bIns="0" rtlCol="0" anchor="t">
+          <a:bodyPr lIns="0" tIns="0" rIns="0" bIns="0" rtlCol="0" anchor="t" wrap="square">
             <a:spAutoFit/>
           </a:bodyPr>
           <a:lstStyle/>
           <a:p>
-            <a:pPr algn="l">
-              <a:lnSpc>
-                <a:spcPts val="10248"/>
-              </a:lnSpc>
-              <a:spcBef>
-                <a:spcPct val="0"/>
-              </a:spcBef>
-            </a:pPr>
-            <a:r>
-              <a:rPr sz="6000" dirty="0">
-                <a:latin typeface="Open Sans Extra Bold"/>
+            <a:r>
+              <a:rPr b="1" sz="4400">
+                <a:solidFill>
+                  <a:srgbClr val="0F172A"/>
+                </a:solidFill>
+                <a:latin typeface="Lato"/>
               </a:rPr>
               <a:t>Introduction</a:t>
             </a:r>
@@ -5071,8 +4941,8 @@
         </p:nvSpPr>
         <p:spPr>
           <a:xfrm>
-            <a:off x="1066801" y="2486901"/>
-            <a:ext cx="8778239" cy="6790449"/>
+            <a:off x="1097280" y="2194560"/>
+            <a:ext cx="8046720" cy="7132320"/>
           </a:xfrm>
           <a:prstGeom prst="rect">
             <a:avLst/>
@@ -5086,31 +4956,27 @@
           <a:p>
             <a:pPr>
               <a:lnSpc>
-                <a:spcPct val="120000"/>
+                <a:spcPct val="118000"/>
               </a:lnSpc>
               <a:spcAft>
                 <a:spcPts val="1400"/>
               </a:spcAft>
             </a:pPr>
             <a:r>
-              <a:rPr sz="2400" b="1" dirty="0">
+              <a:rPr b="1" sz="1700">
                 <a:solidFill>
                   <a:srgbClr val="0F172A"/>
                 </a:solidFill>
-                <a:latin typeface="Lato" panose="020F0502020204030203" pitchFamily="34" charset="0"/>
-                <a:ea typeface="Lato" panose="020F0502020204030203" pitchFamily="34" charset="0"/>
-                <a:cs typeface="Lato" panose="020F0502020204030203" pitchFamily="34" charset="0"/>
+                <a:latin typeface="Lato"/>
               </a:rPr>
               <a:t>Interactive Systems Laboratory:</a:t>
             </a:r>
             <a:r>
-              <a:rPr sz="2400" b="0" dirty="0">
+              <a:rPr b="0" sz="1700">
                 <a:solidFill>
                   <a:srgbClr val="334155"/>
                 </a:solidFill>
-                <a:latin typeface="Lato" panose="020F0502020204030203" pitchFamily="34" charset="0"/>
-                <a:ea typeface="Lato" panose="020F0502020204030203" pitchFamily="34" charset="0"/>
-                <a:cs typeface="Lato" panose="020F0502020204030203" pitchFamily="34" charset="0"/>
+                <a:latin typeface="Lato"/>
               </a:rPr>
               <a:t> Connects theoretical Operating System principles with real algorithmic execution, measurement, vector visualization, and comparative benchmarks.</a:t>
             </a:r>
@@ -5118,31 +4984,27 @@
           <a:p>
             <a:pPr>
               <a:lnSpc>
-                <a:spcPct val="120000"/>
+                <a:spcPct val="118000"/>
               </a:lnSpc>
               <a:spcAft>
                 <a:spcPts val="1400"/>
               </a:spcAft>
             </a:pPr>
             <a:r>
-              <a:rPr sz="2400" b="1" dirty="0">
+              <a:rPr b="1" sz="1700">
                 <a:solidFill>
                   <a:srgbClr val="0F172A"/>
                 </a:solidFill>
-                <a:latin typeface="Lato" panose="020F0502020204030203" pitchFamily="34" charset="0"/>
-                <a:ea typeface="Lato" panose="020F0502020204030203" pitchFamily="34" charset="0"/>
-                <a:cs typeface="Lato" panose="020F0502020204030203" pitchFamily="34" charset="0"/>
+                <a:latin typeface="Lato"/>
               </a:rPr>
               <a:t>Bridging Abstract Theory:</a:t>
             </a:r>
             <a:r>
-              <a:rPr sz="2400" b="0" dirty="0">
+              <a:rPr b="0" sz="1700">
                 <a:solidFill>
                   <a:srgbClr val="334155"/>
                 </a:solidFill>
-                <a:latin typeface="Lato" panose="020F0502020204030203" pitchFamily="34" charset="0"/>
-                <a:ea typeface="Lato" panose="020F0502020204030203" pitchFamily="34" charset="0"/>
-                <a:cs typeface="Lato" panose="020F0502020204030203" pitchFamily="34" charset="0"/>
+                <a:latin typeface="Lato"/>
               </a:rPr>
               <a:t> Eliminates black-box confusion by demystifying how CPU dispatching, dynamic memory placement, virtual paging, and deadlocks function in practice.</a:t>
             </a:r>
@@ -5150,85 +5012,55 @@
           <a:p>
             <a:pPr>
               <a:lnSpc>
-                <a:spcPct val="120000"/>
+                <a:spcPct val="118000"/>
               </a:lnSpc>
               <a:spcAft>
                 <a:spcPts val="1400"/>
               </a:spcAft>
             </a:pPr>
             <a:r>
-              <a:rPr sz="2400" b="1" dirty="0">
+              <a:rPr b="1" sz="1700">
                 <a:solidFill>
                   <a:srgbClr val="0F172A"/>
                 </a:solidFill>
-                <a:latin typeface="Lato" panose="020F0502020204030203" pitchFamily="34" charset="0"/>
-                <a:ea typeface="Lato" panose="020F0502020204030203" pitchFamily="34" charset="0"/>
-                <a:cs typeface="Lato" panose="020F0502020204030203" pitchFamily="34" charset="0"/>
+                <a:latin typeface="Lato"/>
               </a:rPr>
               <a:t>Dual-Pillar Architecture:</a:t>
             </a:r>
             <a:r>
-              <a:rPr sz="2400" b="0" dirty="0">
+              <a:rPr b="0" sz="1700">
                 <a:solidFill>
                   <a:srgbClr val="334155"/>
                 </a:solidFill>
-                <a:latin typeface="Lato" panose="020F0502020204030203" pitchFamily="34" charset="0"/>
-                <a:ea typeface="Lato" panose="020F0502020204030203" pitchFamily="34" charset="0"/>
-                <a:cs typeface="Lato" panose="020F0502020204030203" pitchFamily="34" charset="0"/>
-              </a:rPr>
-              <a:t> Couples an authoritative C++20 simulation core with real Linux/POSIX kernel interfaces (fork/</a:t>
-            </a:r>
-            <a:r>
-              <a:rPr sz="2400" b="0" dirty="0" err="1">
-                <a:solidFill>
-                  <a:srgbClr val="334155"/>
-                </a:solidFill>
-                <a:latin typeface="Lato" panose="020F0502020204030203" pitchFamily="34" charset="0"/>
-                <a:ea typeface="Lato" panose="020F0502020204030203" pitchFamily="34" charset="0"/>
-                <a:cs typeface="Lato" panose="020F0502020204030203" pitchFamily="34" charset="0"/>
-              </a:rPr>
-              <a:t>execve</a:t>
-            </a:r>
-            <a:r>
-              <a:rPr sz="2400" b="0" dirty="0">
-                <a:solidFill>
-                  <a:srgbClr val="334155"/>
-                </a:solidFill>
-                <a:latin typeface="Lato" panose="020F0502020204030203" pitchFamily="34" charset="0"/>
-                <a:ea typeface="Lato" panose="020F0502020204030203" pitchFamily="34" charset="0"/>
-                <a:cs typeface="Lato" panose="020F0502020204030203" pitchFamily="34" charset="0"/>
-              </a:rPr>
-              <a:t> process trees, anonymous pipes, semaphores, and /proc telemetry).</a:t>
+                <a:latin typeface="Lato"/>
+              </a:rPr>
+              <a:t> Couples an authoritative C++20 simulation core with real Linux/POSIX kernel interfaces (fork/execve process trees, anonymous pipes, semaphores, and /proc telemetry).</a:t>
             </a:r>
           </a:p>
           <a:p>
             <a:pPr>
               <a:lnSpc>
-                <a:spcPct val="120000"/>
+                <a:spcPct val="118000"/>
               </a:lnSpc>
               <a:spcAft>
                 <a:spcPts val="1400"/>
               </a:spcAft>
             </a:pPr>
             <a:r>
-              <a:rPr sz="2400" b="1" dirty="0">
+              <a:rPr b="1" sz="1700">
                 <a:solidFill>
                   <a:srgbClr val="0F172A"/>
                 </a:solidFill>
-                <a:latin typeface="Lato" panose="020F0502020204030203" pitchFamily="34" charset="0"/>
-                <a:ea typeface="Lato" panose="020F0502020204030203" pitchFamily="34" charset="0"/>
-                <a:cs typeface="Lato" panose="020F0502020204030203" pitchFamily="34" charset="0"/>
+                <a:latin typeface="Lato"/>
               </a:rPr>
               <a:t>Production-Grade Web Experience:</a:t>
             </a:r>
             <a:r>
-              <a:rPr sz="2400" b="0" dirty="0">
+              <a:rPr b="0" sz="1700">
                 <a:solidFill>
                   <a:srgbClr val="334155"/>
                 </a:solidFill>
-                <a:latin typeface="Lato" panose="020F0502020204030203" pitchFamily="34" charset="0"/>
-                <a:ea typeface="Lato" panose="020F0502020204030203" pitchFamily="34" charset="0"/>
-                <a:cs typeface="Lato" panose="020F0502020204030203" pitchFamily="34" charset="0"/>
+                <a:latin typeface="Lato"/>
               </a:rPr>
               <a:t> Delivers an accessible, zero-dependency modern light-mode engineering platform inspired by Linear/Geist design guidelines across 10 distinct OS domains.</a:t>
             </a:r>
@@ -5257,8 +5089,8 @@
         </p:blipFill>
         <p:spPr>
           <a:xfrm>
-            <a:off x="14767889" y="0"/>
-            <a:ext cx="2475191" cy="2097206"/>
+            <a:off x="14767559" y="0"/>
+            <a:ext cx="2478024" cy="2093976"/>
           </a:xfrm>
           <a:prstGeom prst="rect">
             <a:avLst/>
@@ -5281,8 +5113,8 @@
         </p:blipFill>
         <p:spPr>
           <a:xfrm>
-            <a:off x="9369184" y="2019300"/>
-            <a:ext cx="8510752" cy="6019800"/>
+            <a:off x="9509760" y="2194560"/>
+            <a:ext cx="8046720" cy="5303520"/>
           </a:xfrm>
           <a:prstGeom prst="rect">
             <a:avLst/>
@@ -5650,30 +5482,25 @@
         </p:nvSpPr>
         <p:spPr>
           <a:xfrm>
-            <a:off x="1723107" y="900442"/>
-            <a:ext cx="9354483" cy="1194686"/>
+            <a:off x="1097280" y="777240"/>
+            <a:ext cx="12801600" cy="1097280"/>
           </a:xfrm>
           <a:prstGeom prst="rect">
             <a:avLst/>
           </a:prstGeom>
         </p:spPr>
         <p:txBody>
-          <a:bodyPr lIns="0" tIns="0" rIns="0" bIns="0" rtlCol="0" anchor="t">
+          <a:bodyPr lIns="0" tIns="0" rIns="0" bIns="0" rtlCol="0" anchor="t" wrap="square">
             <a:spAutoFit/>
           </a:bodyPr>
           <a:lstStyle/>
           <a:p>
-            <a:pPr algn="l">
-              <a:lnSpc>
-                <a:spcPts val="10248"/>
-              </a:lnSpc>
-              <a:spcBef>
-                <a:spcPct val="0"/>
-              </a:spcBef>
-            </a:pPr>
-            <a:r>
-              <a:rPr sz="6000">
-                <a:latin typeface="Open Sans Extra Bold"/>
+            <a:r>
+              <a:rPr b="1" sz="4400">
+                <a:solidFill>
+                  <a:srgbClr val="0F172A"/>
+                </a:solidFill>
+                <a:latin typeface="Lato"/>
               </a:rPr>
               <a:t>Motivation</a:t>
             </a:r>
@@ -5743,8 +5570,8 @@
         </p:nvSpPr>
         <p:spPr>
           <a:xfrm>
-            <a:off x="1097280" y="2286000"/>
-            <a:ext cx="8412480" cy="6858000"/>
+            <a:off x="1097280" y="2194560"/>
+            <a:ext cx="8046720" cy="7132320"/>
           </a:xfrm>
           <a:prstGeom prst="rect">
             <a:avLst/>
@@ -5758,27 +5585,27 @@
           <a:p>
             <a:pPr>
               <a:lnSpc>
-                <a:spcPct val="120000"/>
+                <a:spcPct val="118000"/>
               </a:lnSpc>
               <a:spcAft>
                 <a:spcPts val="1400"/>
               </a:spcAft>
             </a:pPr>
             <a:r>
-              <a:rPr sz="1800" b="1">
+              <a:rPr b="1" sz="1700">
                 <a:solidFill>
                   <a:srgbClr val="0F172A"/>
                 </a:solidFill>
-                <a:latin typeface="Open Sans"/>
+                <a:latin typeface="Lato"/>
               </a:rPr>
               <a:t>High Cognitive Barrier:</a:t>
             </a:r>
             <a:r>
-              <a:rPr sz="1800" b="0">
+              <a:rPr b="0" sz="1700">
                 <a:solidFill>
                   <a:srgbClr val="334155"/>
                 </a:solidFill>
-                <a:latin typeface="Open Sans"/>
+                <a:latin typeface="Lato"/>
               </a:rPr>
               <a:t> Abstract kernel concepts (address translation, multi-queue preemption, Belady's anomaly) are hidden in kernel space and difficult to grasp from static textbook diagrams.</a:t>
             </a:r>
@@ -5786,27 +5613,27 @@
           <a:p>
             <a:pPr>
               <a:lnSpc>
-                <a:spcPct val="120000"/>
+                <a:spcPct val="118000"/>
               </a:lnSpc>
               <a:spcAft>
                 <a:spcPts val="1400"/>
               </a:spcAft>
             </a:pPr>
             <a:r>
-              <a:rPr sz="1800" b="1">
+              <a:rPr b="1" sz="1700">
                 <a:solidFill>
                   <a:srgbClr val="0F172A"/>
                 </a:solidFill>
-                <a:latin typeface="Open Sans"/>
+                <a:latin typeface="Lato"/>
               </a:rPr>
               <a:t>Severe Tool Fragmentation:</a:t>
             </a:r>
             <a:r>
-              <a:rPr sz="1800" b="0">
+              <a:rPr b="0" sz="1700">
                 <a:solidFill>
                   <a:srgbClr val="334155"/>
                 </a:solidFill>
-                <a:latin typeface="Open Sans"/>
+                <a:latin typeface="Lato"/>
               </a:rPr>
               <a:t> Students are forced to switch between disconnected, single-topic CLI programs or abandoned 2000s Java applets with no unified workflow.</a:t>
             </a:r>
@@ -5814,27 +5641,27 @@
           <a:p>
             <a:pPr>
               <a:lnSpc>
-                <a:spcPct val="120000"/>
+                <a:spcPct val="118000"/>
               </a:lnSpc>
               <a:spcAft>
                 <a:spcPts val="1400"/>
               </a:spcAft>
             </a:pPr>
             <a:r>
-              <a:rPr sz="1800" b="1">
+              <a:rPr b="1" sz="1700">
                 <a:solidFill>
                   <a:srgbClr val="0F172A"/>
                 </a:solidFill>
-                <a:latin typeface="Open Sans"/>
+                <a:latin typeface="Lato"/>
               </a:rPr>
               <a:t>Lack of Empirical Verification:</a:t>
             </a:r>
             <a:r>
-              <a:rPr sz="1800" b="0">
+              <a:rPr b="0" sz="1700">
                 <a:solidFill>
                   <a:srgbClr val="334155"/>
                 </a:solidFill>
-                <a:latin typeface="Open Sans"/>
+                <a:latin typeface="Lato"/>
               </a:rPr>
               <a:t> Inability to systematically test and benchmark edge cases (convoy effects, priority inversions, memory fragmentation, and safe vs unsafe state sequences).</a:t>
             </a:r>
@@ -5842,27 +5669,27 @@
           <a:p>
             <a:pPr>
               <a:lnSpc>
-                <a:spcPct val="120000"/>
+                <a:spcPct val="118000"/>
               </a:lnSpc>
               <a:spcAft>
                 <a:spcPts val="1400"/>
               </a:spcAft>
             </a:pPr>
             <a:r>
-              <a:rPr sz="1800" b="1">
+              <a:rPr b="1" sz="1700">
                 <a:solidFill>
                   <a:srgbClr val="0F172A"/>
                 </a:solidFill>
-                <a:latin typeface="Open Sans"/>
+                <a:latin typeface="Lato"/>
               </a:rPr>
               <a:t>Active Learning Methodology:</a:t>
             </a:r>
             <a:r>
-              <a:rPr sz="1800" b="0">
+              <a:rPr b="0" sz="1700">
                 <a:solidFill>
                   <a:srgbClr val="334155"/>
                 </a:solidFill>
-                <a:latin typeface="Open Sans"/>
+                <a:latin typeface="Lato"/>
               </a:rPr>
               <a:t> Addresses the proven pedagogical pipeline: Learn -&gt; Configure Workloads -&gt; Execute C++ Simulation -&gt; Observe Vector Visualizers -&gt; Measure Metrics -&gt; Analyze.</a:t>
             </a:r>
@@ -5891,8 +5718,8 @@
         </p:blipFill>
         <p:spPr>
           <a:xfrm>
-            <a:off x="14762973" y="-2078"/>
-            <a:ext cx="2475191" cy="2097206"/>
+            <a:off x="14767559" y="0"/>
+            <a:ext cx="2478024" cy="2093976"/>
           </a:xfrm>
           <a:prstGeom prst="rect">
             <a:avLst/>
@@ -5915,8 +5742,8 @@
         </p:blipFill>
         <p:spPr>
           <a:xfrm>
-            <a:off x="9875520" y="2377440"/>
-            <a:ext cx="7498079" cy="5303520"/>
+            <a:off x="9509760" y="2194560"/>
+            <a:ext cx="8046720" cy="5303520"/>
           </a:xfrm>
           <a:prstGeom prst="rect">
             <a:avLst/>
@@ -6284,30 +6111,25 @@
         </p:nvSpPr>
         <p:spPr>
           <a:xfrm>
-            <a:off x="1723107" y="900442"/>
-            <a:ext cx="9354483" cy="1194686"/>
+            <a:off x="1097280" y="777240"/>
+            <a:ext cx="12801600" cy="1097280"/>
           </a:xfrm>
           <a:prstGeom prst="rect">
             <a:avLst/>
           </a:prstGeom>
         </p:spPr>
         <p:txBody>
-          <a:bodyPr lIns="0" tIns="0" rIns="0" bIns="0" rtlCol="0" anchor="t">
+          <a:bodyPr lIns="0" tIns="0" rIns="0" bIns="0" rtlCol="0" anchor="t" wrap="square">
             <a:spAutoFit/>
           </a:bodyPr>
           <a:lstStyle/>
           <a:p>
-            <a:pPr algn="l">
-              <a:lnSpc>
-                <a:spcPts val="10248"/>
-              </a:lnSpc>
-              <a:spcBef>
-                <a:spcPct val="0"/>
-              </a:spcBef>
-            </a:pPr>
-            <a:r>
-              <a:rPr sz="6000">
-                <a:latin typeface="Open Sans Extra Bold"/>
+            <a:r>
+              <a:rPr b="1" sz="4400">
+                <a:solidFill>
+                  <a:srgbClr val="0F172A"/>
+                </a:solidFill>
+                <a:latin typeface="Lato"/>
               </a:rPr>
               <a:t>Objective</a:t>
             </a:r>
@@ -6377,8 +6199,8 @@
         </p:nvSpPr>
         <p:spPr>
           <a:xfrm>
-            <a:off x="1828800" y="2377440"/>
-            <a:ext cx="14630400" cy="6858000"/>
+            <a:off x="1645920" y="2194560"/>
+            <a:ext cx="14996159" cy="7132320"/>
           </a:xfrm>
           <a:prstGeom prst="rect">
             <a:avLst/>
@@ -6392,27 +6214,27 @@
           <a:p>
             <a:pPr>
               <a:lnSpc>
-                <a:spcPct val="120000"/>
+                <a:spcPct val="122000"/>
               </a:lnSpc>
               <a:spcAft>
-                <a:spcPts val="1400"/>
+                <a:spcPts val="1800"/>
               </a:spcAft>
             </a:pPr>
             <a:r>
-              <a:rPr sz="2000" b="1">
+              <a:rPr b="1" sz="1900">
                 <a:solidFill>
                   <a:srgbClr val="0F172A"/>
                 </a:solidFill>
-                <a:latin typeface="Open Sans"/>
+                <a:latin typeface="Lato"/>
               </a:rPr>
               <a:t>Unified 10-Module Suite:</a:t>
             </a:r>
             <a:r>
-              <a:rPr sz="2000" b="0">
+              <a:rPr b="0" sz="1900">
                 <a:solidFill>
                   <a:srgbClr val="334155"/>
                 </a:solidFill>
-                <a:latin typeface="Open Sans"/>
+                <a:latin typeface="Lato"/>
               </a:rPr>
               <a:t> Build a comprehensive laboratory covering CPU Scheduling, Dynamic Memory, Page Replacement, Banker's Deadlock Avoidance, Disk Arm Seek, Virtual Memory MMU, File Systems, Process Lifecycle, POSIX Concurrency, and Host Telemetry.</a:t>
             </a:r>
@@ -6420,27 +6242,27 @@
           <a:p>
             <a:pPr>
               <a:lnSpc>
-                <a:spcPct val="120000"/>
+                <a:spcPct val="122000"/>
               </a:lnSpc>
               <a:spcAft>
-                <a:spcPts val="1400"/>
+                <a:spcPts val="1800"/>
               </a:spcAft>
             </a:pPr>
             <a:r>
-              <a:rPr sz="2000" b="1">
+              <a:rPr b="1" sz="1900">
                 <a:solidFill>
                   <a:srgbClr val="0F172A"/>
                 </a:solidFill>
-                <a:latin typeface="Open Sans"/>
+                <a:latin typeface="Lato"/>
               </a:rPr>
               <a:t>High-Precision Vector Visualizers:</a:t>
             </a:r>
             <a:r>
-              <a:rPr sz="2000" b="0">
+              <a:rPr b="0" sz="1900">
                 <a:solidFill>
                   <a:srgbClr val="334155"/>
                 </a:solidFill>
-                <a:latin typeface="Open Sans"/>
+                <a:latin typeface="Lato"/>
               </a:rPr>
               <a:t> Implement native SVG rendering for Gantt charts with millisecond guidelines, memory maps with fragmentation analysis, step-by-step frame steppers, and cylinder seek plots.</a:t>
             </a:r>
@@ -6448,27 +6270,27 @@
           <a:p>
             <a:pPr>
               <a:lnSpc>
-                <a:spcPct val="120000"/>
+                <a:spcPct val="122000"/>
               </a:lnSpc>
               <a:spcAft>
-                <a:spcPts val="1400"/>
+                <a:spcPts val="1800"/>
               </a:spcAft>
             </a:pPr>
             <a:r>
-              <a:rPr sz="2000" b="1">
+              <a:rPr b="1" sz="1900">
                 <a:solidFill>
                   <a:srgbClr val="0F172A"/>
                 </a:solidFill>
-                <a:latin typeface="Open Sans"/>
+                <a:latin typeface="Lato"/>
               </a:rPr>
               <a:t>Authoritative C++ Core &amp; Deterministic Benchmarking:</a:t>
             </a:r>
             <a:r>
-              <a:rPr sz="2000" b="0">
+              <a:rPr b="0" sz="1900">
                 <a:solidFill>
                   <a:srgbClr val="334155"/>
                 </a:solidFill>
-                <a:latin typeface="Open Sans"/>
+                <a:latin typeface="Lato"/>
               </a:rPr>
               <a:t> Connect simulations to a compiled C++20 engine verified by 356 GoogleTests, providing reproducible textbook presets (Belady's anomaly, convoy effect, safe sequence).</a:t>
             </a:r>
@@ -6476,27 +6298,27 @@
           <a:p>
             <a:pPr>
               <a:lnSpc>
-                <a:spcPct val="120000"/>
+                <a:spcPct val="122000"/>
               </a:lnSpc>
               <a:spcAft>
-                <a:spcPts val="1400"/>
+                <a:spcPts val="1800"/>
               </a:spcAft>
             </a:pPr>
             <a:r>
-              <a:rPr sz="2000" b="1">
+              <a:rPr b="1" sz="1900">
                 <a:solidFill>
                   <a:srgbClr val="0F172A"/>
                 </a:solidFill>
-                <a:latin typeface="Open Sans"/>
+                <a:latin typeface="Lato"/>
               </a:rPr>
               <a:t>Dual Modern Interface:</a:t>
             </a:r>
             <a:r>
-              <a:rPr sz="2000" b="0">
+              <a:rPr b="0" sz="1900">
                 <a:solidFill>
                   <a:srgbClr val="334155"/>
                 </a:solidFill>
-                <a:latin typeface="Open Sans"/>
+                <a:latin typeface="Lato"/>
               </a:rPr>
               <a:t> Deliver a zero-dependency light-mode web application and a native PySide6 desktop GUI with 150 automated end-to-end pytest tests.</a:t>
             </a:r>
@@ -6525,8 +6347,8 @@
         </p:blipFill>
         <p:spPr>
           <a:xfrm>
-            <a:off x="14762973" y="-2078"/>
-            <a:ext cx="2475191" cy="2097206"/>
+            <a:off x="14767559" y="0"/>
+            <a:ext cx="2478024" cy="2093976"/>
           </a:xfrm>
           <a:prstGeom prst="rect">
             <a:avLst/>
@@ -6894,30 +6716,25 @@
         </p:nvSpPr>
         <p:spPr>
           <a:xfrm>
-            <a:off x="1723107" y="900442"/>
-            <a:ext cx="9354483" cy="1194686"/>
+            <a:off x="1097280" y="777240"/>
+            <a:ext cx="12801600" cy="1097280"/>
           </a:xfrm>
           <a:prstGeom prst="rect">
             <a:avLst/>
           </a:prstGeom>
         </p:spPr>
         <p:txBody>
-          <a:bodyPr lIns="0" tIns="0" rIns="0" bIns="0" rtlCol="0" anchor="t">
+          <a:bodyPr lIns="0" tIns="0" rIns="0" bIns="0" rtlCol="0" anchor="t" wrap="square">
             <a:spAutoFit/>
           </a:bodyPr>
           <a:lstStyle/>
           <a:p>
-            <a:pPr algn="l">
-              <a:lnSpc>
-                <a:spcPts val="10248"/>
-              </a:lnSpc>
-              <a:spcBef>
-                <a:spcPct val="0"/>
-              </a:spcBef>
-            </a:pPr>
-            <a:r>
-              <a:rPr sz="6000">
-                <a:latin typeface="Open Sans Extra Bold"/>
+            <a:r>
+              <a:rPr b="1" sz="4400">
+                <a:solidFill>
+                  <a:srgbClr val="0F172A"/>
+                </a:solidFill>
+                <a:latin typeface="Lato"/>
               </a:rPr>
               <a:t>System Architecture</a:t>
             </a:r>
@@ -6987,8 +6804,8 @@
         </p:nvSpPr>
         <p:spPr>
           <a:xfrm>
-            <a:off x="1097280" y="2286000"/>
-            <a:ext cx="8412480" cy="6858000"/>
+            <a:off x="1097280" y="2194560"/>
+            <a:ext cx="8046720" cy="7132320"/>
           </a:xfrm>
           <a:prstGeom prst="rect">
             <a:avLst/>
@@ -7002,27 +6819,27 @@
           <a:p>
             <a:pPr>
               <a:lnSpc>
-                <a:spcPct val="120000"/>
+                <a:spcPct val="118000"/>
               </a:lnSpc>
               <a:spcAft>
                 <a:spcPts val="1400"/>
               </a:spcAft>
             </a:pPr>
             <a:r>
-              <a:rPr sz="1800" b="1">
+              <a:rPr b="1" sz="1700">
                 <a:solidFill>
                   <a:srgbClr val="0F172A"/>
                 </a:solidFill>
-                <a:latin typeface="Open Sans"/>
+                <a:latin typeface="Lato"/>
               </a:rPr>
               <a:t>Tier 1 (Presentation Layer):</a:t>
             </a:r>
             <a:r>
-              <a:rPr sz="1800" b="0">
+              <a:rPr b="0" sz="1700">
                 <a:solidFill>
                   <a:srgbClr val="334155"/>
                 </a:solidFill>
-                <a:latin typeface="Open Sans"/>
+                <a:latin typeface="Lato"/>
               </a:rPr>
               <a:t> Modern Light-Mode Single Page Application (HTML5 / CSS3 / Vanilla ES6+) + Native PySide6 (Qt 6) Desktop GUI. Features custom inline SVG stroke icons.</a:t>
             </a:r>
@@ -7030,27 +6847,27 @@
           <a:p>
             <a:pPr>
               <a:lnSpc>
-                <a:spcPct val="120000"/>
+                <a:spcPct val="118000"/>
               </a:lnSpc>
               <a:spcAft>
                 <a:spcPts val="1400"/>
               </a:spcAft>
             </a:pPr>
             <a:r>
-              <a:rPr sz="1800" b="1">
+              <a:rPr b="1" sz="1700">
                 <a:solidFill>
                   <a:srgbClr val="0F172A"/>
                 </a:solidFill>
-                <a:latin typeface="Open Sans"/>
+                <a:latin typeface="Lato"/>
               </a:rPr>
               <a:t>Tier 2 (Application &amp; REST API Layer):</a:t>
             </a:r>
             <a:r>
-              <a:rPr sz="1800" b="0">
+              <a:rPr b="0" sz="1700">
                 <a:solidFill>
                   <a:srgbClr val="334155"/>
                 </a:solidFill>
-                <a:latin typeface="Open Sans"/>
+                <a:latin typeface="Lato"/>
               </a:rPr>
               <a:t> Python 3.12 Multi-Threaded HTTP Server (ThreadingHTTPServer) with zero external pip dependencies routing JSON endpoints (/api/*/run).</a:t>
             </a:r>
@@ -7058,27 +6875,27 @@
           <a:p>
             <a:pPr>
               <a:lnSpc>
-                <a:spcPct val="120000"/>
+                <a:spcPct val="118000"/>
               </a:lnSpc>
               <a:spcAft>
                 <a:spcPts val="1400"/>
               </a:spcAft>
             </a:pPr>
             <a:r>
-              <a:rPr sz="1800" b="1">
+              <a:rPr b="1" sz="1700">
                 <a:solidFill>
                   <a:srgbClr val="0F172A"/>
                 </a:solidFill>
-                <a:latin typeface="Open Sans"/>
+                <a:latin typeface="Lato"/>
               </a:rPr>
               <a:t>Tier 3 (Platform Execution Bridge):</a:t>
             </a:r>
             <a:r>
-              <a:rPr sz="1800" b="0">
+              <a:rPr b="0" sz="1700">
                 <a:solidFill>
                   <a:srgbClr val="334155"/>
                 </a:solidFill>
-                <a:latin typeface="Open Sans"/>
+                <a:latin typeface="Lato"/>
               </a:rPr>
               <a:t> Automated environment runner supporting native Linux and Windows WSL 2 (wsl.exe), handling CLI argument marshaling and telemetry streaming.</a:t>
             </a:r>
@@ -7086,27 +6903,27 @@
           <a:p>
             <a:pPr>
               <a:lnSpc>
-                <a:spcPct val="120000"/>
+                <a:spcPct val="118000"/>
               </a:lnSpc>
               <a:spcAft>
                 <a:spcPts val="1400"/>
               </a:spcAft>
             </a:pPr>
             <a:r>
-              <a:rPr sz="1800" b="1">
+              <a:rPr b="1" sz="1700">
                 <a:solidFill>
                   <a:srgbClr val="0F172A"/>
                 </a:solidFill>
-                <a:latin typeface="Open Sans"/>
+                <a:latin typeface="Lato"/>
               </a:rPr>
               <a:t>Tier 4 (Authoritative Simulation Core):</a:t>
             </a:r>
             <a:r>
-              <a:rPr sz="1800" b="0">
+              <a:rPr b="0" sz="1700">
                 <a:solidFill>
                   <a:srgbClr val="334155"/>
                 </a:solidFill>
-                <a:latin typeface="Open Sans"/>
+                <a:latin typeface="Lato"/>
               </a:rPr>
               <a:t> Compiled C++20 engine executing deterministic algorithms, real POSIX system calls (fork, execve, pipe, sem_t), and /proc parser.</a:t>
             </a:r>
@@ -7135,8 +6952,8 @@
         </p:blipFill>
         <p:spPr>
           <a:xfrm>
-            <a:off x="14762973" y="0"/>
-            <a:ext cx="2475191" cy="2097206"/>
+            <a:off x="14767559" y="0"/>
+            <a:ext cx="2478024" cy="2093976"/>
           </a:xfrm>
           <a:prstGeom prst="rect">
             <a:avLst/>
@@ -7159,8 +6976,8 @@
         </p:blipFill>
         <p:spPr>
           <a:xfrm>
-            <a:off x="9875520" y="2377440"/>
-            <a:ext cx="7498079" cy="5303520"/>
+            <a:off x="9509760" y="2194560"/>
+            <a:ext cx="8046720" cy="5303520"/>
           </a:xfrm>
           <a:prstGeom prst="rect">
             <a:avLst/>
@@ -7528,30 +7345,25 @@
         </p:nvSpPr>
         <p:spPr>
           <a:xfrm>
-            <a:off x="1723107" y="900442"/>
-            <a:ext cx="9354483" cy="1194686"/>
+            <a:off x="1097280" y="777240"/>
+            <a:ext cx="12801600" cy="1097280"/>
           </a:xfrm>
           <a:prstGeom prst="rect">
             <a:avLst/>
           </a:prstGeom>
         </p:spPr>
         <p:txBody>
-          <a:bodyPr lIns="0" tIns="0" rIns="0" bIns="0" rtlCol="0" anchor="t">
+          <a:bodyPr lIns="0" tIns="0" rIns="0" bIns="0" rtlCol="0" anchor="t" wrap="square">
             <a:spAutoFit/>
           </a:bodyPr>
           <a:lstStyle/>
           <a:p>
-            <a:pPr algn="l">
-              <a:lnSpc>
-                <a:spcPts val="10248"/>
-              </a:lnSpc>
-              <a:spcBef>
-                <a:spcPct val="0"/>
-              </a:spcBef>
-            </a:pPr>
-            <a:r>
-              <a:rPr sz="6000">
-                <a:latin typeface="Open Sans Extra Bold"/>
+            <a:r>
+              <a:rPr b="1" sz="4400">
+                <a:solidFill>
+                  <a:srgbClr val="0F172A"/>
+                </a:solidFill>
+                <a:latin typeface="Lato"/>
               </a:rPr>
               <a:t>Tech Stack</a:t>
             </a:r>
@@ -7621,8 +7433,8 @@
         </p:nvSpPr>
         <p:spPr>
           <a:xfrm>
-            <a:off x="1828800" y="2377440"/>
-            <a:ext cx="14630400" cy="6858000"/>
+            <a:off x="1645920" y="2194560"/>
+            <a:ext cx="14996159" cy="7132320"/>
           </a:xfrm>
           <a:prstGeom prst="rect">
             <a:avLst/>
@@ -7636,27 +7448,27 @@
           <a:p>
             <a:pPr>
               <a:lnSpc>
-                <a:spcPct val="120000"/>
+                <a:spcPct val="122000"/>
               </a:lnSpc>
               <a:spcAft>
-                <a:spcPts val="1400"/>
+                <a:spcPts val="2000"/>
               </a:spcAft>
             </a:pPr>
             <a:r>
-              <a:rPr sz="2000" b="1">
+              <a:rPr b="1" sz="2000">
                 <a:solidFill>
                   <a:srgbClr val="0F172A"/>
                 </a:solidFill>
-                <a:latin typeface="Open Sans"/>
+                <a:latin typeface="Lato"/>
               </a:rPr>
               <a:t>Core Simulation Engine:</a:t>
             </a:r>
             <a:r>
-              <a:rPr sz="2000" b="0">
+              <a:rPr b="0" sz="2000">
                 <a:solidFill>
                   <a:srgbClr val="334155"/>
                 </a:solidFill>
-                <a:latin typeface="Open Sans"/>
+                <a:latin typeface="Lato"/>
               </a:rPr>
               <a:t> C++20 (Modern ISO C++), CMake 3.20+, GoogleTest (356 unit tests), POSIX APIs (&lt;unistd.h&gt;, &lt;semaphore.h&gt;).</a:t>
             </a:r>
@@ -7664,27 +7476,27 @@
           <a:p>
             <a:pPr>
               <a:lnSpc>
-                <a:spcPct val="120000"/>
+                <a:spcPct val="122000"/>
               </a:lnSpc>
               <a:spcAft>
-                <a:spcPts val="1400"/>
+                <a:spcPts val="2000"/>
               </a:spcAft>
             </a:pPr>
             <a:r>
-              <a:rPr sz="2000" b="1">
+              <a:rPr b="1" sz="2000">
                 <a:solidFill>
                   <a:srgbClr val="0F172A"/>
                 </a:solidFill>
-                <a:latin typeface="Open Sans"/>
+                <a:latin typeface="Lato"/>
               </a:rPr>
               <a:t>Backend &amp; API Server:</a:t>
             </a:r>
             <a:r>
-              <a:rPr sz="2000" b="0">
+              <a:rPr b="0" sz="2000">
                 <a:solidFill>
                   <a:srgbClr val="334155"/>
                 </a:solidFill>
-                <a:latin typeface="Open Sans"/>
+                <a:latin typeface="Lato"/>
               </a:rPr>
               <a:t> Python 3.12 Standard Library (http.server.ThreadingHTTPServer - zero external pip dependencies), Subprocess / WSL 2 execution runner.</a:t>
             </a:r>
@@ -7692,27 +7504,27 @@
           <a:p>
             <a:pPr>
               <a:lnSpc>
-                <a:spcPct val="120000"/>
+                <a:spcPct val="122000"/>
               </a:lnSpc>
               <a:spcAft>
-                <a:spcPts val="1400"/>
+                <a:spcPts val="2000"/>
               </a:spcAft>
             </a:pPr>
             <a:r>
-              <a:rPr sz="2000" b="1">
+              <a:rPr b="1" sz="2000">
                 <a:solidFill>
                   <a:srgbClr val="0F172A"/>
                 </a:solidFill>
-                <a:latin typeface="Open Sans"/>
+                <a:latin typeface="Lato"/>
               </a:rPr>
               <a:t>Modern Web Frontend:</a:t>
             </a:r>
             <a:r>
-              <a:rPr sz="2000" b="0">
+              <a:rPr b="0" sz="2000">
                 <a:solidFill>
                   <a:srgbClr val="334155"/>
                 </a:solidFill>
-                <a:latin typeface="Open Sans"/>
+                <a:latin typeface="Lato"/>
               </a:rPr>
               <a:t> Vanilla JavaScript (ES6+), HTML5, CSS3 Custom Properties (Linear/Geist Light Mode Design System), Vector SVG Engine (Lucide-standard icons).</a:t>
             </a:r>
@@ -7720,27 +7532,27 @@
           <a:p>
             <a:pPr>
               <a:lnSpc>
-                <a:spcPct val="120000"/>
+                <a:spcPct val="122000"/>
               </a:lnSpc>
               <a:spcAft>
-                <a:spcPts val="1400"/>
+                <a:spcPts val="2000"/>
               </a:spcAft>
             </a:pPr>
             <a:r>
-              <a:rPr sz="2000" b="1">
+              <a:rPr b="1" sz="2000">
                 <a:solidFill>
                   <a:srgbClr val="0F172A"/>
                 </a:solidFill>
-                <a:latin typeface="Open Sans"/>
+                <a:latin typeface="Lato"/>
               </a:rPr>
               <a:t>Desktop GUI &amp; Testing:</a:t>
             </a:r>
             <a:r>
-              <a:rPr sz="2000" b="0">
+              <a:rPr b="0" sz="2000">
                 <a:solidFill>
                   <a:srgbClr val="334155"/>
                 </a:solidFill>
-                <a:latin typeface="Open Sans"/>
+                <a:latin typeface="Lato"/>
               </a:rPr>
               <a:t> PySide6 (Qt 6), Pytest 9.2 (150 automated tests), GitHub Actions CI pipeline.</a:t>
             </a:r>
@@ -7769,8 +7581,8 @@
         </p:blipFill>
         <p:spPr>
           <a:xfrm>
-            <a:off x="14762973" y="0"/>
-            <a:ext cx="2475191" cy="2097206"/>
+            <a:off x="14767559" y="0"/>
+            <a:ext cx="2478024" cy="2093976"/>
           </a:xfrm>
           <a:prstGeom prst="rect">
             <a:avLst/>
@@ -8138,30 +7950,25 @@
         </p:nvSpPr>
         <p:spPr>
           <a:xfrm>
-            <a:off x="1723107" y="900442"/>
-            <a:ext cx="9354483" cy="1194686"/>
+            <a:off x="1097280" y="777240"/>
+            <a:ext cx="12801600" cy="1097280"/>
           </a:xfrm>
           <a:prstGeom prst="rect">
             <a:avLst/>
           </a:prstGeom>
         </p:spPr>
         <p:txBody>
-          <a:bodyPr lIns="0" tIns="0" rIns="0" bIns="0" rtlCol="0" anchor="t">
+          <a:bodyPr lIns="0" tIns="0" rIns="0" bIns="0" rtlCol="0" anchor="t" wrap="square">
             <a:spAutoFit/>
           </a:bodyPr>
           <a:lstStyle/>
           <a:p>
-            <a:pPr algn="l">
-              <a:lnSpc>
-                <a:spcPts val="10248"/>
-              </a:lnSpc>
-              <a:spcBef>
-                <a:spcPct val="0"/>
-              </a:spcBef>
-            </a:pPr>
-            <a:r>
-              <a:rPr sz="6000">
-                <a:latin typeface="Open Sans Extra Bold"/>
+            <a:r>
+              <a:rPr b="1" sz="4400">
+                <a:solidFill>
+                  <a:srgbClr val="0F172A"/>
+                </a:solidFill>
+                <a:latin typeface="Lato"/>
               </a:rPr>
               <a:t>References</a:t>
             </a:r>
@@ -8231,8 +8038,8 @@
         </p:nvSpPr>
         <p:spPr>
           <a:xfrm>
-            <a:off x="1828800" y="2286000"/>
-            <a:ext cx="14630400" cy="7132320"/>
+            <a:off x="1645920" y="2194560"/>
+            <a:ext cx="14996159" cy="7132320"/>
           </a:xfrm>
           <a:prstGeom prst="rect">
             <a:avLst/>
@@ -8246,18 +8053,18 @@
           <a:p>
             <a:pPr>
               <a:lnSpc>
-                <a:spcPct val="120000"/>
+                <a:spcPct val="122000"/>
               </a:lnSpc>
               <a:spcAft>
-                <a:spcPts val="1400"/>
+                <a:spcPts val="1600"/>
               </a:spcAft>
             </a:pPr>
             <a:r>
-              <a:rPr sz="1800" b="0">
-                <a:solidFill>
-                  <a:srgbClr val="0F172A"/>
-                </a:solidFill>
-                <a:latin typeface="Open Sans"/>
+              <a:rPr b="0" sz="1800">
+                <a:solidFill>
+                  <a:srgbClr val="334155"/>
+                </a:solidFill>
+                <a:latin typeface="Lato"/>
               </a:rPr>
               <a:t>Silberschatz, A., Galvin, P. B., &amp; Gagne, G. (2021). Operating System Concepts (10th ed.). John Wiley &amp; Sons.</a:t>
             </a:r>
@@ -8265,18 +8072,18 @@
           <a:p>
             <a:pPr>
               <a:lnSpc>
-                <a:spcPct val="120000"/>
+                <a:spcPct val="122000"/>
               </a:lnSpc>
               <a:spcAft>
-                <a:spcPts val="1400"/>
+                <a:spcPts val="1600"/>
               </a:spcAft>
             </a:pPr>
             <a:r>
-              <a:rPr sz="1800" b="0">
-                <a:solidFill>
-                  <a:srgbClr val="0F172A"/>
-                </a:solidFill>
-                <a:latin typeface="Open Sans"/>
+              <a:rPr b="0" sz="1800">
+                <a:solidFill>
+                  <a:srgbClr val="334155"/>
+                </a:solidFill>
+                <a:latin typeface="Lato"/>
               </a:rPr>
               <a:t>Tanenbaum, A. S., &amp; Bos, H. (2023). Modern Operating Systems (5th ed.). Pearson Education.</a:t>
             </a:r>
@@ -8284,18 +8091,18 @@
           <a:p>
             <a:pPr>
               <a:lnSpc>
-                <a:spcPct val="120000"/>
+                <a:spcPct val="122000"/>
               </a:lnSpc>
               <a:spcAft>
-                <a:spcPts val="1400"/>
+                <a:spcPts val="1600"/>
               </a:spcAft>
             </a:pPr>
             <a:r>
-              <a:rPr sz="1800" b="0">
-                <a:solidFill>
-                  <a:srgbClr val="0F172A"/>
-                </a:solidFill>
-                <a:latin typeface="Open Sans"/>
+              <a:rPr b="0" sz="1800">
+                <a:solidFill>
+                  <a:srgbClr val="334155"/>
+                </a:solidFill>
+                <a:latin typeface="Lato"/>
               </a:rPr>
               <a:t>Al-Kharabsheh, K. et al. (2022). "Evaluating Interactive Visual Simulators for Operating Systems Education." IEEE Transactions on Learning Technologies, 15(3), 340-352.</a:t>
             </a:r>
@@ -8303,18 +8110,18 @@
           <a:p>
             <a:pPr>
               <a:lnSpc>
-                <a:spcPct val="120000"/>
+                <a:spcPct val="122000"/>
               </a:lnSpc>
               <a:spcAft>
-                <a:spcPts val="1400"/>
+                <a:spcPts val="1600"/>
               </a:spcAft>
             </a:pPr>
             <a:r>
-              <a:rPr sz="1800" b="0">
-                <a:solidFill>
-                  <a:srgbClr val="0F172A"/>
-                </a:solidFill>
-                <a:latin typeface="Open Sans"/>
+              <a:rPr b="0" sz="1800">
+                <a:solidFill>
+                  <a:srgbClr val="334155"/>
+                </a:solidFill>
+                <a:latin typeface="Lato"/>
               </a:rPr>
               <a:t>Robbins, K. A., &amp; Robbins, S. (2020). "Practical UNIX and Systems Programming Visualization." ACM Technical Symposium on Computer Science Education (SIGCSE), 52(1), 112-118.</a:t>
             </a:r>
@@ -8322,18 +8129,18 @@
           <a:p>
             <a:pPr>
               <a:lnSpc>
-                <a:spcPct val="120000"/>
+                <a:spcPct val="122000"/>
               </a:lnSpc>
               <a:spcAft>
-                <a:spcPts val="1400"/>
+                <a:spcPts val="1600"/>
               </a:spcAft>
             </a:pPr>
             <a:r>
-              <a:rPr sz="1800" b="0">
-                <a:solidFill>
-                  <a:srgbClr val="0F172A"/>
-                </a:solidFill>
-                <a:latin typeface="Open Sans"/>
+              <a:rPr b="0" sz="1800">
+                <a:solidFill>
+                  <a:srgbClr val="334155"/>
+                </a:solidFill>
+                <a:latin typeface="Lato"/>
               </a:rPr>
               <a:t>Love, R. (2018). Linux Kernel Development (3rd ed.). Addison-Wesley Professional.</a:t>
             </a:r>
@@ -8362,8 +8169,8 @@
         </p:blipFill>
         <p:spPr>
           <a:xfrm>
-            <a:off x="14762973" y="-2078"/>
-            <a:ext cx="2475191" cy="2097206"/>
+            <a:off x="14767559" y="0"/>
+            <a:ext cx="2478024" cy="2093976"/>
           </a:xfrm>
           <a:prstGeom prst="rect">
             <a:avLst/>
@@ -8731,30 +8538,25 @@
         </p:nvSpPr>
         <p:spPr>
           <a:xfrm>
-            <a:off x="1723107" y="900442"/>
-            <a:ext cx="9354483" cy="1194686"/>
+            <a:off x="1097280" y="777240"/>
+            <a:ext cx="12801600" cy="1097280"/>
           </a:xfrm>
           <a:prstGeom prst="rect">
             <a:avLst/>
           </a:prstGeom>
         </p:spPr>
         <p:txBody>
-          <a:bodyPr lIns="0" tIns="0" rIns="0" bIns="0" rtlCol="0" anchor="t">
+          <a:bodyPr lIns="0" tIns="0" rIns="0" bIns="0" rtlCol="0" anchor="t" wrap="square">
             <a:spAutoFit/>
           </a:bodyPr>
           <a:lstStyle/>
           <a:p>
-            <a:pPr algn="l">
-              <a:lnSpc>
-                <a:spcPts val="10248"/>
-              </a:lnSpc>
-              <a:spcBef>
-                <a:spcPct val="0"/>
-              </a:spcBef>
-            </a:pPr>
-            <a:r>
-              <a:rPr sz="6000">
-                <a:latin typeface="Open Sans Extra Bold"/>
+            <a:r>
+              <a:rPr b="1" sz="4400">
+                <a:solidFill>
+                  <a:srgbClr val="0F172A"/>
+                </a:solidFill>
+                <a:latin typeface="Lato"/>
               </a:rPr>
               <a:t>Conclusion</a:t>
             </a:r>
@@ -8824,8 +8626,8 @@
         </p:nvSpPr>
         <p:spPr>
           <a:xfrm>
-            <a:off x="1828800" y="2377440"/>
-            <a:ext cx="14630400" cy="6858000"/>
+            <a:off x="1645920" y="2194560"/>
+            <a:ext cx="14996159" cy="7132320"/>
           </a:xfrm>
           <a:prstGeom prst="rect">
             <a:avLst/>
@@ -8839,27 +8641,27 @@
           <a:p>
             <a:pPr>
               <a:lnSpc>
-                <a:spcPct val="120000"/>
+                <a:spcPct val="122000"/>
               </a:lnSpc>
               <a:spcAft>
-                <a:spcPts val="1400"/>
+                <a:spcPts val="2000"/>
               </a:spcAft>
             </a:pPr>
             <a:r>
-              <a:rPr sz="2000" b="1">
+              <a:rPr b="1" sz="2000">
                 <a:solidFill>
                   <a:srgbClr val="0F172A"/>
                 </a:solidFill>
-                <a:latin typeface="Open Sans"/>
+                <a:latin typeface="Lato"/>
               </a:rPr>
               <a:t>Comprehensive Integration:</a:t>
             </a:r>
             <a:r>
-              <a:rPr sz="2000" b="0">
+              <a:rPr b="0" sz="2000">
                 <a:solidFill>
                   <a:srgbClr val="334155"/>
                 </a:solidFill>
-                <a:latin typeface="Open Sans"/>
+                <a:latin typeface="Lato"/>
               </a:rPr>
               <a:t> Successfully unified 10 core Operating Systems domains into a single production-quality laboratory platform.</a:t>
             </a:r>
@@ -8867,27 +8669,27 @@
           <a:p>
             <a:pPr>
               <a:lnSpc>
-                <a:spcPct val="120000"/>
+                <a:spcPct val="122000"/>
               </a:lnSpc>
               <a:spcAft>
-                <a:spcPts val="1400"/>
+                <a:spcPts val="2000"/>
               </a:spcAft>
             </a:pPr>
             <a:r>
-              <a:rPr sz="2000" b="1">
+              <a:rPr b="1" sz="2000">
                 <a:solidFill>
                   <a:srgbClr val="0F172A"/>
                 </a:solidFill>
-                <a:latin typeface="Open Sans"/>
+                <a:latin typeface="Lato"/>
               </a:rPr>
               <a:t>Pedagogical Impact:</a:t>
             </a:r>
             <a:r>
-              <a:rPr sz="2000" b="0">
+              <a:rPr b="0" sz="2000">
                 <a:solidFill>
                   <a:srgbClr val="334155"/>
                 </a:solidFill>
-                <a:latin typeface="Open Sans"/>
+                <a:latin typeface="Lato"/>
               </a:rPr>
               <a:t> Bridges abstract theoretical textbook models with concrete visual execution, enabling intuitive experimentation for CS students.</a:t>
             </a:r>
@@ -8895,27 +8697,27 @@
           <a:p>
             <a:pPr>
               <a:lnSpc>
-                <a:spcPct val="120000"/>
+                <a:spcPct val="122000"/>
               </a:lnSpc>
               <a:spcAft>
-                <a:spcPts val="1400"/>
+                <a:spcPts val="2000"/>
               </a:spcAft>
             </a:pPr>
             <a:r>
-              <a:rPr sz="2000" b="1">
+              <a:rPr b="1" sz="2000">
                 <a:solidFill>
                   <a:srgbClr val="0F172A"/>
                 </a:solidFill>
-                <a:latin typeface="Open Sans"/>
+                <a:latin typeface="Lato"/>
               </a:rPr>
               <a:t>Engineering Rigor:</a:t>
             </a:r>
             <a:r>
-              <a:rPr sz="2000" b="0">
+              <a:rPr b="0" sz="2000">
                 <a:solidFill>
                   <a:srgbClr val="334155"/>
                 </a:solidFill>
-                <a:latin typeface="Open Sans"/>
+                <a:latin typeface="Lato"/>
               </a:rPr>
               <a:t> Combines high-performance C++20 simulation accuracy with real POSIX kernel integration and 150 automated verification tests.</a:t>
             </a:r>
@@ -8923,27 +8725,27 @@
           <a:p>
             <a:pPr>
               <a:lnSpc>
-                <a:spcPct val="120000"/>
+                <a:spcPct val="122000"/>
               </a:lnSpc>
               <a:spcAft>
-                <a:spcPts val="1400"/>
+                <a:spcPts val="2000"/>
               </a:spcAft>
             </a:pPr>
             <a:r>
-              <a:rPr sz="2000" b="1">
+              <a:rPr b="1" sz="2000">
                 <a:solidFill>
                   <a:srgbClr val="0F172A"/>
                 </a:solidFill>
-                <a:latin typeface="Open Sans"/>
+                <a:latin typeface="Lato"/>
               </a:rPr>
               <a:t>Accessible Deployment:</a:t>
             </a:r>
             <a:r>
-              <a:rPr sz="2000" b="0">
+              <a:rPr b="0" sz="2000">
                 <a:solidFill>
                   <a:srgbClr val="334155"/>
                 </a:solidFill>
-                <a:latin typeface="Open Sans"/>
+                <a:latin typeface="Lato"/>
               </a:rPr>
               <a:t> Zero external pip dependencies, instant browser launch, and modern light-theme devtool ergonomics.</a:t>
             </a:r>
@@ -8972,8 +8774,8 @@
         </p:blipFill>
         <p:spPr>
           <a:xfrm>
-            <a:off x="14762973" y="0"/>
-            <a:ext cx="2475191" cy="2097206"/>
+            <a:off x="14767559" y="0"/>
+            <a:ext cx="2478024" cy="2093976"/>
           </a:xfrm>
           <a:prstGeom prst="rect">
             <a:avLst/>

</xml_diff>